<commit_message>
modificaciones menores PPTs clase 1, 5 y 6
</commit_message>
<xml_diff>
--- a/clase1/teorica_1.pptx
+++ b/clase1/teorica_1.pptx
@@ -66,19 +66,15 @@
   <p:notesSz cx="6858000" cy="9144000"/>
   <p:embeddedFontLst>
     <p:embeddedFont>
-      <p:font typeface="MS Mincho" panose="02020609040205080304" pitchFamily="49" charset="-128"/>
+      <p:font typeface="Cambria Math" panose="02040503050406030204" pitchFamily="18" charset="0"/>
       <p:regular r:id="rId56"/>
     </p:embeddedFont>
     <p:embeddedFont>
-      <p:font typeface="Cambria Math" panose="02040503050406030204" pitchFamily="18" charset="0"/>
+      <p:font typeface="Proxima Nova" panose="020B0604020202020204" charset="0"/>
       <p:regular r:id="rId57"/>
-    </p:embeddedFont>
-    <p:embeddedFont>
-      <p:font typeface="Proxima Nova" panose="020B0604020202020204" charset="0"/>
-      <p:regular r:id="rId58"/>
-      <p:bold r:id="rId59"/>
-      <p:italic r:id="rId60"/>
-      <p:boldItalic r:id="rId61"/>
+      <p:bold r:id="rId58"/>
+      <p:italic r:id="rId59"/>
+      <p:boldItalic r:id="rId60"/>
     </p:embeddedFont>
   </p:embeddedFontLst>
   <p:defaultTextStyle>
@@ -14149,7 +14145,27 @@
             </a:pPr>
             <a:r>
               <a:rPr lang="es-AR" dirty="0"/>
-              <a:t>Dr. Desarrollo Económico UNQUI</a:t>
+              <a:t>Dr. Desarrollo Económico UNQ</a:t>
+            </a:r>
+          </a:p>
+          <a:p>
+            <a:pPr lvl="0" algn="l" rtl="0">
+              <a:lnSpc>
+                <a:spcPct val="115000"/>
+              </a:lnSpc>
+              <a:spcBef>
+                <a:spcPts val="0"/>
+              </a:spcBef>
+              <a:spcAft>
+                <a:spcPts val="0"/>
+              </a:spcAft>
+              <a:buSzPts val="1800"/>
+              <a:buFont typeface="Wingdings" panose="05000000000000000000" pitchFamily="2" charset="2"/>
+              <a:buChar char="§"/>
+            </a:pPr>
+            <a:r>
+              <a:rPr lang="es-AR" dirty="0"/>
+              <a:t>Investigador en CEPED-UBA</a:t>
             </a:r>
           </a:p>
           <a:p>

</xml_diff>

<commit_message>
corrijo rar clase 1
</commit_message>
<xml_diff>
--- a/clase1/teorica_1.pptx
+++ b/clase1/teorica_1.pptx
@@ -14117,15 +14117,7 @@
             </a:r>
             <a:r>
               <a:rPr lang="en-GB" dirty="0"/>
-              <a:t>. </a:t>
-            </a:r>
-            <a:r>
-              <a:rPr lang="en-GB" dirty="0" err="1"/>
-              <a:t>Economía</a:t>
-            </a:r>
-            <a:r>
-              <a:rPr lang="en-GB" dirty="0"/>
-              <a:t> UBA</a:t>
+              <a:t>. Economía (FCE-UBA)</a:t>
             </a:r>
           </a:p>
           <a:p>
@@ -14145,7 +14137,7 @@
             </a:pPr>
             <a:r>
               <a:rPr lang="es-AR" dirty="0"/>
-              <a:t>Dr. Desarrollo Económico UNQ</a:t>
+              <a:t>Dr. Desarrollo Económico (UNQ)</a:t>
             </a:r>
           </a:p>
           <a:p>
@@ -14165,7 +14157,7 @@
             </a:pPr>
             <a:r>
               <a:rPr lang="es-AR" dirty="0"/>
-              <a:t>Investigador en CEPED-UBA</a:t>
+              <a:t>Investigador en CEPED (CONICET/UBA)</a:t>
             </a:r>
           </a:p>
           <a:p>
@@ -14201,8 +14193,8 @@
         </p:nvSpPr>
         <p:spPr>
           <a:xfrm>
-            <a:off x="4771800" y="1152475"/>
-            <a:ext cx="4068000" cy="3416400"/>
+            <a:off x="4771799" y="1152475"/>
+            <a:ext cx="4156611" cy="3416400"/>
           </a:xfrm>
           <a:prstGeom prst="rect">
             <a:avLst/>
@@ -14471,7 +14463,6 @@
           </a:lstStyle>
           <a:p>
             <a:pPr marL="0" indent="0">
-              <a:buFont typeface="Proxima Nova"/>
               <a:buNone/>
             </a:pPr>
             <a:r>
@@ -14480,27 +14471,8 @@
                   <a:schemeClr val="bg2"/>
                 </a:solidFill>
               </a:rPr>
-              <a:t>Santiago Núñez </a:t>
-            </a:r>
-            <a:r>
-              <a:rPr lang="es-MX" sz="2400" b="1" dirty="0" err="1">
-                <a:solidFill>
-                  <a:schemeClr val="bg2"/>
-                </a:solidFill>
-              </a:rPr>
-              <a:t>Rimedio</a:t>
-            </a:r>
-            <a:endParaRPr lang="es-MX" sz="2400" b="1" dirty="0">
-              <a:solidFill>
-                <a:schemeClr val="bg2"/>
-              </a:solidFill>
-            </a:endParaRPr>
-          </a:p>
-          <a:p>
-            <a:pPr marL="114300" indent="0">
-              <a:buFont typeface="Proxima Nova"/>
-              <a:buNone/>
-            </a:pPr>
+              <a:t>Magalí Rodrigues Pires</a:t>
+            </a:r>
             <a:endParaRPr lang="es-MX" sz="2400" dirty="0"/>
           </a:p>
           <a:p>
@@ -14508,10 +14480,7 @@
               <a:buFont typeface="Wingdings" panose="05000000000000000000" pitchFamily="2" charset="2"/>
               <a:buChar char="§"/>
             </a:pPr>
-            <a:r>
-              <a:rPr lang="es-MX" dirty="0"/>
-              <a:t>Estudiante avanzado de Antropología Social UNSAM</a:t>
-            </a:r>
+            <a:endParaRPr lang="es-MX" dirty="0"/>
           </a:p>
           <a:p>
             <a:pPr>
@@ -14519,22 +14488,29 @@
               <a:buChar char="§"/>
             </a:pPr>
             <a:r>
-              <a:rPr lang="es-MX" dirty="0"/>
-              <a:t>Asistente de investigación </a:t>
-            </a:r>
-            <a:r>
-              <a:rPr lang="es-MX" dirty="0" err="1"/>
-              <a:t>Factor</a:t>
-            </a:r>
-            <a:r>
-              <a:rPr lang="es-MX" sz="1200" dirty="0" err="1"/>
-              <a:t>~</a:t>
-            </a:r>
-            <a:r>
-              <a:rPr lang="es-MX" dirty="0" err="1"/>
-              <a:t>Data</a:t>
-            </a:r>
-            <a:endParaRPr lang="es-MX" dirty="0"/>
+              <a:rPr lang="es-ES" dirty="0"/>
+              <a:t>Lic. en Sociología (FSOC - UBA)</a:t>
+            </a:r>
+          </a:p>
+          <a:p>
+            <a:pPr>
+              <a:buFont typeface="Wingdings" panose="05000000000000000000" pitchFamily="2" charset="2"/>
+              <a:buChar char="§"/>
+            </a:pPr>
+            <a:r>
+              <a:rPr lang="es-ES" dirty="0"/>
+              <a:t>Maestría en Explotación de Datos y Descubrimiento del Conocimiento (FCEN - UBA)</a:t>
+            </a:r>
+          </a:p>
+          <a:p>
+            <a:pPr>
+              <a:buFont typeface="Wingdings" panose="05000000000000000000" pitchFamily="2" charset="2"/>
+              <a:buChar char="§"/>
+            </a:pPr>
+            <a:r>
+              <a:rPr lang="es-ES" dirty="0"/>
+              <a:t>Científica de Datos</a:t>
+            </a:r>
           </a:p>
           <a:p>
             <a:pPr marL="0" indent="0">

</xml_diff>